<commit_message>
Reporte portadas en pptx. Falta radio
</commit_message>
<xml_diff>
--- a/Reporte 310826.pptx
+++ b/Reporte 310826.pptx
@@ -5,7 +5,7 @@
     <p:sldMasterId id="2147483672" r:id="rId1"/>
   </p:sldMasterIdLst>
   <p:notesMasterIdLst>
-    <p:notesMasterId r:id="rId18"/>
+    <p:notesMasterId r:id="rId19"/>
   </p:notesMasterIdLst>
   <p:sldIdLst>
     <p:sldId id="350" r:id="rId2"/>
@@ -13,32 +13,33 @@
     <p:sldId id="408" r:id="rId4"/>
     <p:sldId id="405" r:id="rId5"/>
     <p:sldId id="406" r:id="rId6"/>
-    <p:sldId id="394" r:id="rId7"/>
-    <p:sldId id="395" r:id="rId8"/>
-    <p:sldId id="396" r:id="rId9"/>
-    <p:sldId id="403" r:id="rId10"/>
-    <p:sldId id="388" r:id="rId11"/>
-    <p:sldId id="351" r:id="rId12"/>
-    <p:sldId id="361" r:id="rId13"/>
-    <p:sldId id="412" r:id="rId14"/>
-    <p:sldId id="371" r:id="rId15"/>
-    <p:sldId id="413" r:id="rId16"/>
-    <p:sldId id="280" r:id="rId17"/>
+    <p:sldId id="414" r:id="rId7"/>
+    <p:sldId id="394" r:id="rId8"/>
+    <p:sldId id="395" r:id="rId9"/>
+    <p:sldId id="396" r:id="rId10"/>
+    <p:sldId id="403" r:id="rId11"/>
+    <p:sldId id="388" r:id="rId12"/>
+    <p:sldId id="351" r:id="rId13"/>
+    <p:sldId id="361" r:id="rId14"/>
+    <p:sldId id="412" r:id="rId15"/>
+    <p:sldId id="371" r:id="rId16"/>
+    <p:sldId id="413" r:id="rId17"/>
+    <p:sldId id="280" r:id="rId18"/>
   </p:sldIdLst>
   <p:sldSz cx="9144000" cy="5143500" type="screen16x9"/>
   <p:notesSz cx="6858000" cy="9144000"/>
   <p:embeddedFontLst>
     <p:embeddedFont>
       <p:font typeface="Montserrat" panose="00000500000000000000" pitchFamily="2" charset="0"/>
-      <p:regular r:id="rId19"/>
-      <p:bold r:id="rId20"/>
-      <p:italic r:id="rId21"/>
-      <p:boldItalic r:id="rId22"/>
+      <p:regular r:id="rId20"/>
+      <p:bold r:id="rId21"/>
+      <p:italic r:id="rId22"/>
+      <p:boldItalic r:id="rId23"/>
     </p:embeddedFont>
     <p:embeddedFont>
       <p:font typeface="Montserrat Black" panose="00000A00000000000000" pitchFamily="2" charset="0"/>
-      <p:bold r:id="rId23"/>
-      <p:boldItalic r:id="rId24"/>
+      <p:bold r:id="rId24"/>
+      <p:boldItalic r:id="rId25"/>
     </p:embeddedFont>
   </p:embeddedFontLst>
   <p:defaultTextStyle>
@@ -1085,6 +1086,90 @@
         <p:cNvPr id="1" name="">
           <a:extLst>
             <a:ext uri="{FF2B5EF4-FFF2-40B4-BE49-F238E27FC236}">
+              <a16:creationId xmlns:a16="http://schemas.microsoft.com/office/drawing/2014/main" id="{66771407-C47D-552B-05E4-A75AA367F770}"/>
+            </a:ext>
+          </a:extLst>
+        </p:cNvPr>
+        <p:cNvGrpSpPr/>
+        <p:nvPr/>
+      </p:nvGrpSpPr>
+      <p:grpSpPr>
+        <a:xfrm>
+          <a:off x="0" y="0"/>
+          <a:ext cx="0" cy="0"/>
+          <a:chOff x="0" y="0"/>
+          <a:chExt cx="0" cy="0"/>
+        </a:xfrm>
+      </p:grpSpPr>
+      <p:sp>
+        <p:nvSpPr>
+          <p:cNvPr id="2" name="Marcador de imagen de diapositiva 1">
+            <a:extLst>
+              <a:ext uri="{FF2B5EF4-FFF2-40B4-BE49-F238E27FC236}">
+                <a16:creationId xmlns:a16="http://schemas.microsoft.com/office/drawing/2014/main" id="{CF2852E1-BD12-611E-DDFC-64F979C5F187}"/>
+              </a:ext>
+            </a:extLst>
+          </p:cNvPr>
+          <p:cNvSpPr>
+            <a:spLocks noGrp="1" noRot="1" noChangeAspect="1"/>
+          </p:cNvSpPr>
+          <p:nvPr>
+            <p:ph type="sldImg"/>
+          </p:nvPr>
+        </p:nvSpPr>
+        <p:spPr>
+          <a:xfrm>
+            <a:off x="381000" y="685800"/>
+            <a:ext cx="6096000" cy="3429000"/>
+          </a:xfrm>
+        </p:spPr>
+      </p:sp>
+      <p:sp>
+        <p:nvSpPr>
+          <p:cNvPr id="3" name="Marcador de notas 2">
+            <a:extLst>
+              <a:ext uri="{FF2B5EF4-FFF2-40B4-BE49-F238E27FC236}">
+                <a16:creationId xmlns:a16="http://schemas.microsoft.com/office/drawing/2014/main" id="{D963736E-0897-EEE6-768D-4C6AA2C81228}"/>
+              </a:ext>
+            </a:extLst>
+          </p:cNvPr>
+          <p:cNvSpPr>
+            <a:spLocks noGrp="1"/>
+          </p:cNvSpPr>
+          <p:nvPr>
+            <p:ph type="body" idx="1"/>
+          </p:nvPr>
+        </p:nvSpPr>
+        <p:spPr/>
+        <p:txBody>
+          <a:bodyPr/>
+          <a:lstStyle/>
+          <a:p>
+            <a:endParaRPr lang="es-MX" dirty="0"/>
+          </a:p>
+        </p:txBody>
+      </p:sp>
+    </p:spTree>
+    <p:extLst>
+      <p:ext uri="{BB962C8B-B14F-4D97-AF65-F5344CB8AC3E}">
+        <p14:creationId xmlns:p14="http://schemas.microsoft.com/office/powerpoint/2010/main" val="4068728817"/>
+      </p:ext>
+    </p:extLst>
+  </p:cSld>
+  <p:clrMapOvr>
+    <a:masterClrMapping/>
+  </p:clrMapOvr>
+</p:notes>
+</file>
+
+<file path=ppt/notesSlides/notesSlide6.xml><?xml version="1.0" encoding="utf-8"?>
+<p:notes xmlns:a="http://schemas.openxmlformats.org/drawingml/2006/main" xmlns:r="http://schemas.openxmlformats.org/officeDocument/2006/relationships" xmlns:p="http://schemas.openxmlformats.org/presentationml/2006/main">
+  <p:cSld>
+    <p:spTree>
+      <p:nvGrpSpPr>
+        <p:cNvPr id="1" name="">
+          <a:extLst>
+            <a:ext uri="{FF2B5EF4-FFF2-40B4-BE49-F238E27FC236}">
               <a16:creationId xmlns:a16="http://schemas.microsoft.com/office/drawing/2014/main" id="{357567EE-3B4E-8C48-2AAD-0C70B0A7FC91}"/>
             </a:ext>
           </a:extLst>
@@ -1161,7 +1246,7 @@
 </p:notes>
 </file>
 
-<file path=ppt/notesSlides/notesSlide6.xml><?xml version="1.0" encoding="utf-8"?>
+<file path=ppt/notesSlides/notesSlide7.xml><?xml version="1.0" encoding="utf-8"?>
 <p:notes xmlns:a="http://schemas.openxmlformats.org/drawingml/2006/main" xmlns:r="http://schemas.openxmlformats.org/officeDocument/2006/relationships" xmlns:p="http://schemas.openxmlformats.org/presentationml/2006/main" showMasterSp="0" showMasterPhAnim="0">
   <p:cSld>
     <p:spTree>
@@ -6419,7 +6504,7 @@
                 <a:latin typeface="Montserrat Black"/>
                 <a:sym typeface="Arial"/>
               </a:rPr>
-              <a:t>Elaborado: 28</a:t>
+              <a:t>Elaborado: 31</a:t>
             </a:r>
             <a:r>
               <a:rPr lang="es-MX" sz="1600" dirty="0">
@@ -6483,6 +6568,124 @@
 </file>
 
 <file path=ppt/slides/slide10.xml><?xml version="1.0" encoding="utf-8"?>
+<p:sld xmlns:a="http://schemas.openxmlformats.org/drawingml/2006/main" xmlns:r="http://schemas.openxmlformats.org/officeDocument/2006/relationships" xmlns:p="http://schemas.openxmlformats.org/presentationml/2006/main">
+  <p:cSld>
+    <p:bg>
+      <p:bgPr>
+        <a:solidFill>
+          <a:srgbClr val="FAFAFA"/>
+        </a:solidFill>
+        <a:effectLst/>
+      </p:bgPr>
+    </p:bg>
+    <p:spTree>
+      <p:nvGrpSpPr>
+        <p:cNvPr id="1" name="">
+          <a:extLst>
+            <a:ext uri="{FF2B5EF4-FFF2-40B4-BE49-F238E27FC236}">
+              <a16:creationId xmlns:a16="http://schemas.microsoft.com/office/drawing/2014/main" id="{93B6DC8C-E619-F67B-9048-4615CF198885}"/>
+            </a:ext>
+          </a:extLst>
+        </p:cNvPr>
+        <p:cNvGrpSpPr/>
+        <p:nvPr/>
+      </p:nvGrpSpPr>
+      <p:grpSpPr>
+        <a:xfrm>
+          <a:off x="0" y="0"/>
+          <a:ext cx="0" cy="0"/>
+          <a:chOff x="0" y="0"/>
+          <a:chExt cx="0" cy="0"/>
+        </a:xfrm>
+      </p:grpSpPr>
+      <p:sp>
+        <p:nvSpPr>
+          <p:cNvPr id="7" name="CuadroTexto 6">
+            <a:extLst>
+              <a:ext uri="{FF2B5EF4-FFF2-40B4-BE49-F238E27FC236}">
+                <a16:creationId xmlns:a16="http://schemas.microsoft.com/office/drawing/2014/main" id="{C46A5360-EC76-283F-42C4-C3D1585636DD}"/>
+              </a:ext>
+            </a:extLst>
+          </p:cNvPr>
+          <p:cNvSpPr txBox="1"/>
+          <p:nvPr/>
+        </p:nvSpPr>
+        <p:spPr>
+          <a:xfrm>
+            <a:off x="908175" y="152426"/>
+            <a:ext cx="7254625" cy="369332"/>
+          </a:xfrm>
+          <a:prstGeom prst="rect">
+            <a:avLst/>
+          </a:prstGeom>
+          <a:noFill/>
+        </p:spPr>
+        <p:txBody>
+          <a:bodyPr wrap="square">
+            <a:spAutoFit/>
+          </a:bodyPr>
+          <a:lstStyle/>
+          <a:p>
+            <a:pPr algn="ctr">
+              <a:buNone/>
+            </a:pPr>
+            <a:r>
+              <a:rPr lang="es-MX" sz="1800" b="1" i="0" dirty="0">
+                <a:solidFill>
+                  <a:srgbClr val="000000"/>
+                </a:solidFill>
+                <a:effectLst/>
+                <a:latin typeface="Montserrat" pitchFamily="2" charset="0"/>
+              </a:rPr>
+              <a:t>Detalle de Notas en primeras planas</a:t>
+            </a:r>
+          </a:p>
+        </p:txBody>
+      </p:sp>
+      <p:pic>
+        <p:nvPicPr>
+          <p:cNvPr id="4" name="Imagen 3">
+            <a:extLst>
+              <a:ext uri="{FF2B5EF4-FFF2-40B4-BE49-F238E27FC236}">
+                <a16:creationId xmlns:a16="http://schemas.microsoft.com/office/drawing/2014/main" id="{2ECDA0F1-01DF-68E3-F23D-9E1F5204EC96}"/>
+              </a:ext>
+            </a:extLst>
+          </p:cNvPr>
+          <p:cNvPicPr>
+            <a:picLocks noChangeAspect="1"/>
+          </p:cNvPicPr>
+          <p:nvPr/>
+        </p:nvPicPr>
+        <p:blipFill>
+          <a:blip r:embed="rId3"/>
+          <a:stretch>
+            <a:fillRect/>
+          </a:stretch>
+        </p:blipFill>
+        <p:spPr>
+          <a:xfrm>
+            <a:off x="2085628" y="1376195"/>
+            <a:ext cx="4972744" cy="2391109"/>
+          </a:xfrm>
+          <a:prstGeom prst="rect">
+            <a:avLst/>
+          </a:prstGeom>
+        </p:spPr>
+      </p:pic>
+    </p:spTree>
+    <p:extLst>
+      <p:ext uri="{BB962C8B-B14F-4D97-AF65-F5344CB8AC3E}">
+        <p14:creationId xmlns:p14="http://schemas.microsoft.com/office/powerpoint/2010/main" val="2442859157"/>
+      </p:ext>
+    </p:extLst>
+  </p:cSld>
+  <p:clrMapOvr>
+    <a:masterClrMapping/>
+  </p:clrMapOvr>
+</p:sld>
+</file>
+
+<file path=ppt/slides/slide11.xml><?xml version="1.0" encoding="utf-8"?>
 <p:sld xmlns:a="http://schemas.openxmlformats.org/drawingml/2006/main" xmlns:r="http://schemas.openxmlformats.org/officeDocument/2006/relationships" xmlns:p="http://schemas.openxmlformats.org/presentationml/2006/main">
   <p:cSld>
     <p:bg>
@@ -6594,7 +6797,7 @@
 </p:sld>
 </file>
 
-<file path=ppt/slides/slide11.xml><?xml version="1.0" encoding="utf-8"?>
+<file path=ppt/slides/slide12.xml><?xml version="1.0" encoding="utf-8"?>
 <p:sld xmlns:a="http://schemas.openxmlformats.org/drawingml/2006/main" xmlns:r="http://schemas.openxmlformats.org/officeDocument/2006/relationships" xmlns:p="http://schemas.openxmlformats.org/presentationml/2006/main">
   <p:cSld>
     <p:bg>
@@ -6700,7 +6903,7 @@
 </p:sld>
 </file>
 
-<file path=ppt/slides/slide12.xml><?xml version="1.0" encoding="utf-8"?>
+<file path=ppt/slides/slide13.xml><?xml version="1.0" encoding="utf-8"?>
 <p:sld xmlns:a="http://schemas.openxmlformats.org/drawingml/2006/main" xmlns:r="http://schemas.openxmlformats.org/officeDocument/2006/relationships" xmlns:p="http://schemas.openxmlformats.org/presentationml/2006/main">
   <p:cSld>
     <p:bg>
@@ -6806,7 +7009,7 @@
 </p:sld>
 </file>
 
-<file path=ppt/slides/slide13.xml><?xml version="1.0" encoding="utf-8"?>
+<file path=ppt/slides/slide14.xml><?xml version="1.0" encoding="utf-8"?>
 <p:sld xmlns:a="http://schemas.openxmlformats.org/drawingml/2006/main" xmlns:r="http://schemas.openxmlformats.org/officeDocument/2006/relationships" xmlns:p="http://schemas.openxmlformats.org/presentationml/2006/main">
   <p:cSld>
     <p:bg>
@@ -6912,7 +7115,7 @@
 </p:sld>
 </file>
 
-<file path=ppt/slides/slide14.xml><?xml version="1.0" encoding="utf-8"?>
+<file path=ppt/slides/slide15.xml><?xml version="1.0" encoding="utf-8"?>
 <p:sld xmlns:a="http://schemas.openxmlformats.org/drawingml/2006/main" xmlns:r="http://schemas.openxmlformats.org/officeDocument/2006/relationships" xmlns:p="http://schemas.openxmlformats.org/presentationml/2006/main">
   <p:cSld>
     <p:bg>
@@ -7018,7 +7221,7 @@
 </p:sld>
 </file>
 
-<file path=ppt/slides/slide15.xml><?xml version="1.0" encoding="utf-8"?>
+<file path=ppt/slides/slide16.xml><?xml version="1.0" encoding="utf-8"?>
 <p:sld xmlns:a="http://schemas.openxmlformats.org/drawingml/2006/main" xmlns:r="http://schemas.openxmlformats.org/officeDocument/2006/relationships" xmlns:p="http://schemas.openxmlformats.org/presentationml/2006/main">
   <p:cSld>
     <p:bg>
@@ -7130,7 +7333,7 @@
 </p:sld>
 </file>
 
-<file path=ppt/slides/slide16.xml><?xml version="1.0" encoding="utf-8"?>
+<file path=ppt/slides/slide17.xml><?xml version="1.0" encoding="utf-8"?>
 <p:sld xmlns:a="http://schemas.openxmlformats.org/drawingml/2006/main" xmlns:r="http://schemas.openxmlformats.org/officeDocument/2006/relationships" xmlns:p="http://schemas.openxmlformats.org/presentationml/2006/main">
   <p:cSld>
     <p:spTree>
@@ -7263,10 +7466,10 @@
       </p:sp>
       <p:pic>
         <p:nvPicPr>
-          <p:cNvPr id="3" name="Imagen 2">
+          <p:cNvPr id="4" name="Imagen 3">
             <a:extLst>
               <a:ext uri="{FF2B5EF4-FFF2-40B4-BE49-F238E27FC236}">
-                <a16:creationId xmlns:a16="http://schemas.microsoft.com/office/drawing/2014/main" id="{45387CE0-36AC-6436-E5D9-97B45A76B34F}"/>
+                <a16:creationId xmlns:a16="http://schemas.microsoft.com/office/drawing/2014/main" id="{12AF21E3-33EE-8E44-4B77-22CC490FDAB6}"/>
               </a:ext>
             </a:extLst>
           </p:cNvPr>
@@ -7283,8 +7486,8 @@
         </p:blipFill>
         <p:spPr>
           <a:xfrm>
-            <a:off x="0" y="937661"/>
-            <a:ext cx="9144000" cy="3411054"/>
+            <a:off x="0" y="937955"/>
+            <a:ext cx="9144000" cy="3410465"/>
           </a:xfrm>
           <a:prstGeom prst="rect">
             <a:avLst/>
@@ -7377,10 +7580,10 @@
       </p:sp>
       <p:pic>
         <p:nvPicPr>
-          <p:cNvPr id="3" name="Imagen 2">
+          <p:cNvPr id="4" name="Imagen 3">
             <a:extLst>
               <a:ext uri="{FF2B5EF4-FFF2-40B4-BE49-F238E27FC236}">
-                <a16:creationId xmlns:a16="http://schemas.microsoft.com/office/drawing/2014/main" id="{AD632777-3DA5-1A51-90CF-DB5770509D65}"/>
+                <a16:creationId xmlns:a16="http://schemas.microsoft.com/office/drawing/2014/main" id="{B584873E-32C3-C31A-F817-1293095C5FC6}"/>
               </a:ext>
             </a:extLst>
           </p:cNvPr>
@@ -7397,8 +7600,8 @@
         </p:blipFill>
         <p:spPr>
           <a:xfrm>
-            <a:off x="0" y="1400554"/>
-            <a:ext cx="9144000" cy="2485267"/>
+            <a:off x="0" y="1402394"/>
+            <a:ext cx="9144000" cy="2481587"/>
           </a:xfrm>
           <a:prstGeom prst="rect">
             <a:avLst/>
@@ -7491,10 +7694,10 @@
       </p:sp>
       <p:pic>
         <p:nvPicPr>
-          <p:cNvPr id="3" name="Imagen 2">
+          <p:cNvPr id="2" name="Imagen 1">
             <a:extLst>
               <a:ext uri="{FF2B5EF4-FFF2-40B4-BE49-F238E27FC236}">
-                <a16:creationId xmlns:a16="http://schemas.microsoft.com/office/drawing/2014/main" id="{C67A83AD-3DDA-A930-BCB1-37B647934276}"/>
+                <a16:creationId xmlns:a16="http://schemas.microsoft.com/office/drawing/2014/main" id="{974D03F1-DAC3-12E1-C9CB-79D82D24C41D}"/>
               </a:ext>
             </a:extLst>
           </p:cNvPr>
@@ -7511,8 +7714,8 @@
         </p:blipFill>
         <p:spPr>
           <a:xfrm>
-            <a:off x="1106488" y="914940"/>
-            <a:ext cx="6858000" cy="3456495"/>
+            <a:off x="644036" y="663458"/>
+            <a:ext cx="7855928" cy="3959460"/>
           </a:xfrm>
           <a:prstGeom prst="rect">
             <a:avLst/>
@@ -7601,10 +7804,10 @@
       </p:sp>
       <p:pic>
         <p:nvPicPr>
-          <p:cNvPr id="4" name="Imagen 3">
+          <p:cNvPr id="3" name="Imagen 2">
             <a:extLst>
               <a:ext uri="{FF2B5EF4-FFF2-40B4-BE49-F238E27FC236}">
-                <a16:creationId xmlns:a16="http://schemas.microsoft.com/office/drawing/2014/main" id="{1BE92E01-3B16-4FEA-6908-2BBA2578D6D4}"/>
+                <a16:creationId xmlns:a16="http://schemas.microsoft.com/office/drawing/2014/main" id="{5B82BBDA-AF41-7197-0054-F596E2F8080D}"/>
               </a:ext>
             </a:extLst>
           </p:cNvPr>
@@ -7621,8 +7824,8 @@
         </p:blipFill>
         <p:spPr>
           <a:xfrm>
-            <a:off x="1776022" y="1233300"/>
-            <a:ext cx="5591955" cy="2676899"/>
+            <a:off x="594757" y="890353"/>
+            <a:ext cx="7954485" cy="3362794"/>
           </a:xfrm>
           <a:prstGeom prst="rect">
             <a:avLst/>
@@ -7643,6 +7846,116 @@
 </file>
 
 <file path=ppt/slides/slide6.xml><?xml version="1.0" encoding="utf-8"?>
+<p:sld xmlns:a="http://schemas.openxmlformats.org/drawingml/2006/main" xmlns:r="http://schemas.openxmlformats.org/officeDocument/2006/relationships" xmlns:p="http://schemas.openxmlformats.org/presentationml/2006/main">
+  <p:cSld>
+    <p:spTree>
+      <p:nvGrpSpPr>
+        <p:cNvPr id="1" name="">
+          <a:extLst>
+            <a:ext uri="{FF2B5EF4-FFF2-40B4-BE49-F238E27FC236}">
+              <a16:creationId xmlns:a16="http://schemas.microsoft.com/office/drawing/2014/main" id="{D44BC6C1-14F0-D3A2-2AF4-D849FDA77EDD}"/>
+            </a:ext>
+          </a:extLst>
+        </p:cNvPr>
+        <p:cNvGrpSpPr/>
+        <p:nvPr/>
+      </p:nvGrpSpPr>
+      <p:grpSpPr>
+        <a:xfrm>
+          <a:off x="0" y="0"/>
+          <a:ext cx="0" cy="0"/>
+          <a:chOff x="0" y="0"/>
+          <a:chExt cx="0" cy="0"/>
+        </a:xfrm>
+      </p:grpSpPr>
+      <p:sp>
+        <p:nvSpPr>
+          <p:cNvPr id="7" name="CuadroTexto 6">
+            <a:extLst>
+              <a:ext uri="{FF2B5EF4-FFF2-40B4-BE49-F238E27FC236}">
+                <a16:creationId xmlns:a16="http://schemas.microsoft.com/office/drawing/2014/main" id="{0226D576-4455-25B3-F7AD-941077B57FAD}"/>
+              </a:ext>
+            </a:extLst>
+          </p:cNvPr>
+          <p:cNvSpPr txBox="1"/>
+          <p:nvPr/>
+        </p:nvSpPr>
+        <p:spPr>
+          <a:xfrm>
+            <a:off x="908175" y="152426"/>
+            <a:ext cx="7254625" cy="369332"/>
+          </a:xfrm>
+          <a:prstGeom prst="rect">
+            <a:avLst/>
+          </a:prstGeom>
+          <a:noFill/>
+        </p:spPr>
+        <p:txBody>
+          <a:bodyPr wrap="square">
+            <a:spAutoFit/>
+          </a:bodyPr>
+          <a:lstStyle/>
+          <a:p>
+            <a:pPr algn="ctr">
+              <a:buNone/>
+            </a:pPr>
+            <a:r>
+              <a:rPr lang="es-MX" sz="1800" b="1" i="0" dirty="0">
+                <a:solidFill>
+                  <a:srgbClr val="000000"/>
+                </a:solidFill>
+                <a:effectLst/>
+                <a:latin typeface="Montserrat" pitchFamily="2" charset="0"/>
+              </a:rPr>
+              <a:t>Detalle de Notas en primeras planas</a:t>
+            </a:r>
+          </a:p>
+        </p:txBody>
+      </p:sp>
+      <p:pic>
+        <p:nvPicPr>
+          <p:cNvPr id="4" name="Imagen 3">
+            <a:extLst>
+              <a:ext uri="{FF2B5EF4-FFF2-40B4-BE49-F238E27FC236}">
+                <a16:creationId xmlns:a16="http://schemas.microsoft.com/office/drawing/2014/main" id="{EA5B0C81-0E23-4381-100C-39CA3B015AF5}"/>
+              </a:ext>
+            </a:extLst>
+          </p:cNvPr>
+          <p:cNvPicPr>
+            <a:picLocks noChangeAspect="1"/>
+          </p:cNvPicPr>
+          <p:nvPr/>
+        </p:nvPicPr>
+        <p:blipFill>
+          <a:blip r:embed="rId3"/>
+          <a:stretch>
+            <a:fillRect/>
+          </a:stretch>
+        </p:blipFill>
+        <p:spPr>
+          <a:xfrm>
+            <a:off x="524903" y="1528607"/>
+            <a:ext cx="8021169" cy="2229161"/>
+          </a:xfrm>
+          <a:prstGeom prst="rect">
+            <a:avLst/>
+          </a:prstGeom>
+        </p:spPr>
+      </p:pic>
+    </p:spTree>
+    <p:extLst>
+      <p:ext uri="{BB962C8B-B14F-4D97-AF65-F5344CB8AC3E}">
+        <p14:creationId xmlns:p14="http://schemas.microsoft.com/office/powerpoint/2010/main" val="1941412921"/>
+      </p:ext>
+    </p:extLst>
+  </p:cSld>
+  <p:clrMapOvr>
+    <a:masterClrMapping/>
+  </p:clrMapOvr>
+</p:sld>
+</file>
+
+<file path=ppt/slides/slide7.xml><?xml version="1.0" encoding="utf-8"?>
 <p:sld xmlns:a="http://schemas.openxmlformats.org/drawingml/2006/main" xmlns:r="http://schemas.openxmlformats.org/officeDocument/2006/relationships" xmlns:p="http://schemas.openxmlformats.org/presentationml/2006/main">
   <p:cSld>
     <p:bg>
@@ -7715,10 +8028,10 @@
       </p:sp>
       <p:pic>
         <p:nvPicPr>
-          <p:cNvPr id="4" name="Imagen 3">
+          <p:cNvPr id="6" name="Imagen 5">
             <a:extLst>
               <a:ext uri="{FF2B5EF4-FFF2-40B4-BE49-F238E27FC236}">
-                <a16:creationId xmlns:a16="http://schemas.microsoft.com/office/drawing/2014/main" id="{4C7B2959-4E0C-270A-832F-26225926A429}"/>
+                <a16:creationId xmlns:a16="http://schemas.microsoft.com/office/drawing/2014/main" id="{14C111A1-CBB6-05D8-5917-73804379F71C}"/>
               </a:ext>
             </a:extLst>
           </p:cNvPr>
@@ -7735,8 +8048,8 @@
         </p:blipFill>
         <p:spPr>
           <a:xfrm>
-            <a:off x="0" y="978168"/>
-            <a:ext cx="9144000" cy="3330039"/>
+            <a:off x="0" y="932391"/>
+            <a:ext cx="9144000" cy="3421594"/>
           </a:xfrm>
           <a:prstGeom prst="rect">
             <a:avLst/>
@@ -7756,7 +8069,7 @@
 </p:sld>
 </file>
 
-<file path=ppt/slides/slide7.xml><?xml version="1.0" encoding="utf-8"?>
+<file path=ppt/slides/slide8.xml><?xml version="1.0" encoding="utf-8"?>
 <p:sld xmlns:a="http://schemas.openxmlformats.org/drawingml/2006/main" xmlns:r="http://schemas.openxmlformats.org/officeDocument/2006/relationships" xmlns:p="http://schemas.openxmlformats.org/presentationml/2006/main">
   <p:cSld>
     <p:bg>
@@ -7829,10 +8142,10 @@
       </p:sp>
       <p:pic>
         <p:nvPicPr>
-          <p:cNvPr id="2" name="Imagen 1">
+          <p:cNvPr id="3" name="Imagen 2">
             <a:extLst>
               <a:ext uri="{FF2B5EF4-FFF2-40B4-BE49-F238E27FC236}">
-                <a16:creationId xmlns:a16="http://schemas.microsoft.com/office/drawing/2014/main" id="{DC8F2316-B30B-B278-1610-ADAB92CFC4B4}"/>
+                <a16:creationId xmlns:a16="http://schemas.microsoft.com/office/drawing/2014/main" id="{0B8CD1D8-1B30-C577-801E-67A4B91AC8B1}"/>
               </a:ext>
             </a:extLst>
           </p:cNvPr>
@@ -7849,7 +8162,7 @@
         </p:blipFill>
         <p:spPr>
           <a:xfrm>
-            <a:off x="1143000" y="914940"/>
+            <a:off x="1106488" y="914940"/>
             <a:ext cx="6858000" cy="3456495"/>
           </a:xfrm>
           <a:prstGeom prst="rect">
@@ -7870,7 +8183,7 @@
 </p:sld>
 </file>
 
-<file path=ppt/slides/slide8.xml><?xml version="1.0" encoding="utf-8"?>
+<file path=ppt/slides/slide9.xml><?xml version="1.0" encoding="utf-8"?>
 <p:sld xmlns:a="http://schemas.openxmlformats.org/drawingml/2006/main" xmlns:r="http://schemas.openxmlformats.org/officeDocument/2006/relationships" xmlns:p="http://schemas.openxmlformats.org/presentationml/2006/main">
   <p:cSld>
     <p:bg>
@@ -7943,10 +8256,10 @@
       </p:sp>
       <p:pic>
         <p:nvPicPr>
-          <p:cNvPr id="2" name="Imagen 1">
+          <p:cNvPr id="3" name="Imagen 2">
             <a:extLst>
               <a:ext uri="{FF2B5EF4-FFF2-40B4-BE49-F238E27FC236}">
-                <a16:creationId xmlns:a16="http://schemas.microsoft.com/office/drawing/2014/main" id="{AFF8101C-E278-CFBA-A7B7-498C7961C62F}"/>
+                <a16:creationId xmlns:a16="http://schemas.microsoft.com/office/drawing/2014/main" id="{F9A84600-2D72-C1AC-C413-23ABA131F5AE}"/>
               </a:ext>
             </a:extLst>
           </p:cNvPr>
@@ -7963,7 +8276,7 @@
         </p:blipFill>
         <p:spPr>
           <a:xfrm>
-            <a:off x="1143000" y="809752"/>
+            <a:off x="1143000" y="914940"/>
             <a:ext cx="6858000" cy="3456495"/>
           </a:xfrm>
           <a:prstGeom prst="rect">
@@ -7975,124 +8288,6 @@
     <p:extLst>
       <p:ext uri="{BB962C8B-B14F-4D97-AF65-F5344CB8AC3E}">
         <p14:creationId xmlns:p14="http://schemas.microsoft.com/office/powerpoint/2010/main" val="3736623944"/>
-      </p:ext>
-    </p:extLst>
-  </p:cSld>
-  <p:clrMapOvr>
-    <a:masterClrMapping/>
-  </p:clrMapOvr>
-</p:sld>
-</file>
-
-<file path=ppt/slides/slide9.xml><?xml version="1.0" encoding="utf-8"?>
-<p:sld xmlns:a="http://schemas.openxmlformats.org/drawingml/2006/main" xmlns:r="http://schemas.openxmlformats.org/officeDocument/2006/relationships" xmlns:p="http://schemas.openxmlformats.org/presentationml/2006/main">
-  <p:cSld>
-    <p:bg>
-      <p:bgPr>
-        <a:solidFill>
-          <a:srgbClr val="FAFAFA"/>
-        </a:solidFill>
-        <a:effectLst/>
-      </p:bgPr>
-    </p:bg>
-    <p:spTree>
-      <p:nvGrpSpPr>
-        <p:cNvPr id="1" name="">
-          <a:extLst>
-            <a:ext uri="{FF2B5EF4-FFF2-40B4-BE49-F238E27FC236}">
-              <a16:creationId xmlns:a16="http://schemas.microsoft.com/office/drawing/2014/main" id="{93B6DC8C-E619-F67B-9048-4615CF198885}"/>
-            </a:ext>
-          </a:extLst>
-        </p:cNvPr>
-        <p:cNvGrpSpPr/>
-        <p:nvPr/>
-      </p:nvGrpSpPr>
-      <p:grpSpPr>
-        <a:xfrm>
-          <a:off x="0" y="0"/>
-          <a:ext cx="0" cy="0"/>
-          <a:chOff x="0" y="0"/>
-          <a:chExt cx="0" cy="0"/>
-        </a:xfrm>
-      </p:grpSpPr>
-      <p:sp>
-        <p:nvSpPr>
-          <p:cNvPr id="7" name="CuadroTexto 6">
-            <a:extLst>
-              <a:ext uri="{FF2B5EF4-FFF2-40B4-BE49-F238E27FC236}">
-                <a16:creationId xmlns:a16="http://schemas.microsoft.com/office/drawing/2014/main" id="{C46A5360-EC76-283F-42C4-C3D1585636DD}"/>
-              </a:ext>
-            </a:extLst>
-          </p:cNvPr>
-          <p:cNvSpPr txBox="1"/>
-          <p:nvPr/>
-        </p:nvSpPr>
-        <p:spPr>
-          <a:xfrm>
-            <a:off x="908175" y="152426"/>
-            <a:ext cx="7254625" cy="369332"/>
-          </a:xfrm>
-          <a:prstGeom prst="rect">
-            <a:avLst/>
-          </a:prstGeom>
-          <a:noFill/>
-        </p:spPr>
-        <p:txBody>
-          <a:bodyPr wrap="square">
-            <a:spAutoFit/>
-          </a:bodyPr>
-          <a:lstStyle/>
-          <a:p>
-            <a:pPr algn="ctr">
-              <a:buNone/>
-            </a:pPr>
-            <a:r>
-              <a:rPr lang="es-MX" sz="1800" b="1" i="0" dirty="0">
-                <a:solidFill>
-                  <a:srgbClr val="000000"/>
-                </a:solidFill>
-                <a:effectLst/>
-                <a:latin typeface="Montserrat" pitchFamily="2" charset="0"/>
-              </a:rPr>
-              <a:t>Detalle de Notas en primeras planas</a:t>
-            </a:r>
-          </a:p>
-        </p:txBody>
-      </p:sp>
-      <p:pic>
-        <p:nvPicPr>
-          <p:cNvPr id="3" name="Imagen 2">
-            <a:extLst>
-              <a:ext uri="{FF2B5EF4-FFF2-40B4-BE49-F238E27FC236}">
-                <a16:creationId xmlns:a16="http://schemas.microsoft.com/office/drawing/2014/main" id="{CA877747-61D4-6947-92BC-FA61CBD24AF9}"/>
-              </a:ext>
-            </a:extLst>
-          </p:cNvPr>
-          <p:cNvPicPr>
-            <a:picLocks noChangeAspect="1"/>
-          </p:cNvPicPr>
-          <p:nvPr/>
-        </p:nvPicPr>
-        <p:blipFill>
-          <a:blip r:embed="rId3"/>
-          <a:stretch>
-            <a:fillRect/>
-          </a:stretch>
-        </p:blipFill>
-        <p:spPr>
-          <a:xfrm>
-            <a:off x="1823654" y="1581011"/>
-            <a:ext cx="5496692" cy="1981477"/>
-          </a:xfrm>
-          <a:prstGeom prst="rect">
-            <a:avLst/>
-          </a:prstGeom>
-        </p:spPr>
-      </p:pic>
-    </p:spTree>
-    <p:extLst>
-      <p:ext uri="{BB962C8B-B14F-4D97-AF65-F5344CB8AC3E}">
-        <p14:creationId xmlns:p14="http://schemas.microsoft.com/office/powerpoint/2010/main" val="2442859157"/>
       </p:ext>
     </p:extLst>
   </p:cSld>

</xml_diff>